<commit_message>
EP1 deck v2: wider SOA crop, centered, IRR fixed
</commit_message>
<xml_diff>
--- a/content-assets/lagoons-ep1/lagoons-review-ep1.pptx
+++ b/content-assets/lagoons-ep1/lagoons-review-ep1.pptx
@@ -1595,20 +1595,20 @@
         </p:nvSpPr>
         <p:spPr>
           <a:xfrm>
-            <a:off x="548640" y="384048"/>
-            <a:ext cx="7315200" cy="320040"/>
-          </a:xfrm>
-          <a:prstGeom prst="rect">
-            <a:avLst/>
-          </a:prstGeom>
-          <a:noFill/>
-          <a:ln/>
-        </p:spPr>
-        <p:txBody>
-          <a:bodyPr wrap="square" lIns="0" tIns="0" rIns="0" bIns="0" rtlCol="0" anchor="ctr"/>
-          <a:lstStyle/>
-          <a:p>
-            <a:pPr indent="0" marL="0">
+            <a:off x="0" y="384048"/>
+            <a:ext cx="12188952" cy="320040"/>
+          </a:xfrm>
+          <a:prstGeom prst="rect">
+            <a:avLst/>
+          </a:prstGeom>
+          <a:noFill/>
+          <a:ln/>
+        </p:spPr>
+        <p:txBody>
+          <a:bodyPr wrap="square" lIns="0" tIns="0" rIns="0" bIns="0" rtlCol="0" anchor="ctr"/>
+          <a:lstStyle/>
+          <a:p>
+            <a:pPr algn="ctr" indent="0" marL="0">
               <a:buNone/>
             </a:pPr>
             <a:r>
@@ -1634,48 +1634,20 @@
         </p:nvSpPr>
         <p:spPr>
           <a:xfrm>
-            <a:off x="10634472" y="384048"/>
-            <a:ext cx="1005840" cy="320040"/>
-          </a:xfrm>
-          <a:prstGeom prst="rect">
-            <a:avLst/>
-          </a:prstGeom>
-          <a:noFill/>
-          <a:ln/>
-        </p:spPr>
-        <p:txBody>
-          <a:bodyPr wrap="square" lIns="0" tIns="0" rIns="0" bIns="0" rtlCol="0" anchor="ctr"/>
-          <a:lstStyle/>
-          <a:p>
-            <a:pPr algn="r" indent="0" marL="0">
-              <a:buNone/>
-            </a:pPr>
-            <a:endParaRPr lang="en-US" sz="1200" dirty="0"/>
-          </a:p>
-        </p:txBody>
-      </p:sp>
-      <p:sp>
-        <p:nvSpPr>
-          <p:cNvPr id="4" name="Text 2"/>
-          <p:cNvSpPr/>
-          <p:nvPr/>
-        </p:nvSpPr>
-        <p:spPr>
-          <a:xfrm>
-            <a:off x="822960" y="1920240"/>
-            <a:ext cx="10515600" cy="822960"/>
-          </a:xfrm>
-          <a:prstGeom prst="rect">
-            <a:avLst/>
-          </a:prstGeom>
-          <a:noFill/>
-          <a:ln/>
-        </p:spPr>
-        <p:txBody>
-          <a:bodyPr wrap="square" lIns="0" tIns="0" rIns="0" bIns="0" rtlCol="0" anchor="ctr"/>
-          <a:lstStyle/>
-          <a:p>
-            <a:pPr indent="0" marL="0">
+            <a:off x="0" y="2011680"/>
+            <a:ext cx="12188952" cy="822960"/>
+          </a:xfrm>
+          <a:prstGeom prst="rect">
+            <a:avLst/>
+          </a:prstGeom>
+          <a:noFill/>
+          <a:ln/>
+        </p:spPr>
+        <p:txBody>
+          <a:bodyPr wrap="square" lIns="0" tIns="0" rIns="0" bIns="0" rtlCol="0" anchor="ctr"/>
+          <a:lstStyle/>
+          <a:p>
+            <a:pPr algn="ctr" indent="0" marL="0">
               <a:buNone/>
             </a:pPr>
             <a:r>
@@ -1695,26 +1667,26 @@
       </p:sp>
       <p:sp>
         <p:nvSpPr>
-          <p:cNvPr id="5" name="Text 3"/>
-          <p:cNvSpPr/>
-          <p:nvPr/>
-        </p:nvSpPr>
-        <p:spPr>
-          <a:xfrm>
-            <a:off x="822960" y="2743200"/>
-            <a:ext cx="10515600" cy="1097280"/>
-          </a:xfrm>
-          <a:prstGeom prst="rect">
-            <a:avLst/>
-          </a:prstGeom>
-          <a:noFill/>
-          <a:ln/>
-        </p:spPr>
-        <p:txBody>
-          <a:bodyPr wrap="square" lIns="0" tIns="0" rIns="0" bIns="0" rtlCol="0" anchor="ctr"/>
-          <a:lstStyle/>
-          <a:p>
-            <a:pPr indent="0" marL="0">
+          <p:cNvPr id="4" name="Text 2"/>
+          <p:cNvSpPr/>
+          <p:nvPr/>
+        </p:nvSpPr>
+        <p:spPr>
+          <a:xfrm>
+            <a:off x="0" y="2834640"/>
+            <a:ext cx="12188952" cy="1097280"/>
+          </a:xfrm>
+          <a:prstGeom prst="rect">
+            <a:avLst/>
+          </a:prstGeom>
+          <a:noFill/>
+          <a:ln/>
+        </p:spPr>
+        <p:txBody>
+          <a:bodyPr wrap="square" lIns="0" tIns="0" rIns="0" bIns="0" rtlCol="0" anchor="ctr"/>
+          <a:lstStyle/>
+          <a:p>
+            <a:pPr algn="ctr" indent="0" marL="0">
               <a:buNone/>
             </a:pPr>
             <a:r>
@@ -1734,26 +1706,26 @@
       </p:sp>
       <p:sp>
         <p:nvSpPr>
-          <p:cNvPr id="6" name="Text 4"/>
-          <p:cNvSpPr/>
-          <p:nvPr/>
-        </p:nvSpPr>
-        <p:spPr>
-          <a:xfrm>
-            <a:off x="822960" y="4114800"/>
-            <a:ext cx="10515600" cy="365760"/>
-          </a:xfrm>
-          <a:prstGeom prst="rect">
-            <a:avLst/>
-          </a:prstGeom>
-          <a:noFill/>
-          <a:ln/>
-        </p:spPr>
-        <p:txBody>
-          <a:bodyPr wrap="square" lIns="0" tIns="0" rIns="0" bIns="0" rtlCol="0" anchor="ctr"/>
-          <a:lstStyle/>
-          <a:p>
-            <a:pPr indent="0" marL="0">
+          <p:cNvPr id="5" name="Text 3"/>
+          <p:cNvSpPr/>
+          <p:nvPr/>
+        </p:nvSpPr>
+        <p:spPr>
+          <a:xfrm>
+            <a:off x="0" y="4206240"/>
+            <a:ext cx="12188952" cy="365760"/>
+          </a:xfrm>
+          <a:prstGeom prst="rect">
+            <a:avLst/>
+          </a:prstGeom>
+          <a:noFill/>
+          <a:ln/>
+        </p:spPr>
+        <p:txBody>
+          <a:bodyPr wrap="square" lIns="0" tIns="0" rIns="0" bIns="0" rtlCol="0" anchor="ctr"/>
+          <a:lstStyle/>
+          <a:p>
+            <a:pPr algn="ctr" indent="0" marL="0">
               <a:buNone/>
             </a:pPr>
             <a:r>
@@ -1773,26 +1745,26 @@
       </p:sp>
       <p:sp>
         <p:nvSpPr>
-          <p:cNvPr id="7" name="Text 5"/>
-          <p:cNvSpPr/>
-          <p:nvPr/>
-        </p:nvSpPr>
-        <p:spPr>
-          <a:xfrm>
-            <a:off x="822960" y="6126480"/>
-            <a:ext cx="5486400" cy="365760"/>
-          </a:xfrm>
-          <a:prstGeom prst="rect">
-            <a:avLst/>
-          </a:prstGeom>
-          <a:noFill/>
-          <a:ln/>
-        </p:spPr>
-        <p:txBody>
-          <a:bodyPr wrap="square" lIns="0" tIns="0" rIns="0" bIns="0" rtlCol="0" anchor="ctr"/>
-          <a:lstStyle/>
-          <a:p>
-            <a:pPr indent="0" marL="0">
+          <p:cNvPr id="6" name="Text 4"/>
+          <p:cNvSpPr/>
+          <p:nvPr/>
+        </p:nvSpPr>
+        <p:spPr>
+          <a:xfrm>
+            <a:off x="0" y="6126480"/>
+            <a:ext cx="12188952" cy="365760"/>
+          </a:xfrm>
+          <a:prstGeom prst="rect">
+            <a:avLst/>
+          </a:prstGeom>
+          <a:noFill/>
+          <a:ln/>
+        </p:spPr>
+        <p:txBody>
+          <a:bodyPr wrap="square" lIns="0" tIns="0" rIns="0" bIns="0" rtlCol="0" anchor="ctr"/>
+          <a:lstStyle/>
+          <a:p>
+            <a:pPr algn="ctr" indent="0" marL="0">
               <a:buNone/>
             </a:pPr>
             <a:r>
@@ -1889,20 +1861,20 @@
         </p:nvSpPr>
         <p:spPr>
           <a:xfrm>
-            <a:off x="548640" y="384048"/>
-            <a:ext cx="7315200" cy="320040"/>
-          </a:xfrm>
-          <a:prstGeom prst="rect">
-            <a:avLst/>
-          </a:prstGeom>
-          <a:noFill/>
-          <a:ln/>
-        </p:spPr>
-        <p:txBody>
-          <a:bodyPr wrap="square" lIns="0" tIns="0" rIns="0" bIns="0" rtlCol="0" anchor="ctr"/>
-          <a:lstStyle/>
-          <a:p>
-            <a:pPr indent="0" marL="0">
+            <a:off x="0" y="384048"/>
+            <a:ext cx="12188952" cy="320040"/>
+          </a:xfrm>
+          <a:prstGeom prst="rect">
+            <a:avLst/>
+          </a:prstGeom>
+          <a:noFill/>
+          <a:ln/>
+        </p:spPr>
+        <p:txBody>
+          <a:bodyPr wrap="square" lIns="0" tIns="0" rIns="0" bIns="0" rtlCol="0" anchor="ctr"/>
+          <a:lstStyle/>
+          <a:p>
+            <a:pPr algn="ctr" indent="0" marL="0">
               <a:buNone/>
             </a:pPr>
             <a:r>
@@ -1928,8 +1900,8 @@
         </p:nvSpPr>
         <p:spPr>
           <a:xfrm>
-            <a:off x="10634472" y="384048"/>
-            <a:ext cx="1005840" cy="320040"/>
+            <a:off x="11000232" y="384048"/>
+            <a:ext cx="640080" cy="320040"/>
           </a:xfrm>
           <a:prstGeom prst="rect">
             <a:avLst/>
@@ -1945,7 +1917,7 @@
               <a:buNone/>
             </a:pPr>
             <a:r>
-              <a:rPr lang="en-US" sz="1200" b="1" spc="300" kern="0" dirty="0">
+              <a:rPr lang="en-US" sz="1200" b="1" dirty="0">
                 <a:solidFill>
                   <a:srgbClr val="E8C96B"/>
                 </a:solidFill>
@@ -1967,20 +1939,20 @@
         </p:nvSpPr>
         <p:spPr>
           <a:xfrm>
-            <a:off x="822960" y="4206240"/>
-            <a:ext cx="7315200" cy="731520"/>
-          </a:xfrm>
-          <a:prstGeom prst="rect">
-            <a:avLst/>
-          </a:prstGeom>
-          <a:noFill/>
-          <a:ln/>
-        </p:spPr>
-        <p:txBody>
-          <a:bodyPr wrap="square" lIns="0" tIns="0" rIns="0" bIns="0" rtlCol="0" anchor="ctr"/>
-          <a:lstStyle/>
-          <a:p>
-            <a:pPr indent="0" marL="0">
+            <a:off x="0" y="4114800"/>
+            <a:ext cx="12188952" cy="731520"/>
+          </a:xfrm>
+          <a:prstGeom prst="rect">
+            <a:avLst/>
+          </a:prstGeom>
+          <a:noFill/>
+          <a:ln/>
+        </p:spPr>
+        <p:txBody>
+          <a:bodyPr wrap="square" lIns="0" tIns="0" rIns="0" bIns="0" rtlCol="0" anchor="ctr"/>
+          <a:lstStyle/>
+          <a:p>
+            <a:pPr algn="ctr" indent="0" marL="0">
               <a:buNone/>
             </a:pPr>
             <a:r>
@@ -2006,20 +1978,20 @@
         </p:nvSpPr>
         <p:spPr>
           <a:xfrm>
-            <a:off x="822960" y="5029200"/>
-            <a:ext cx="7315200" cy="457200"/>
-          </a:xfrm>
-          <a:prstGeom prst="rect">
-            <a:avLst/>
-          </a:prstGeom>
-          <a:noFill/>
-          <a:ln/>
-        </p:spPr>
-        <p:txBody>
-          <a:bodyPr wrap="square" lIns="0" tIns="0" rIns="0" bIns="0" rtlCol="0" anchor="ctr"/>
-          <a:lstStyle/>
-          <a:p>
-            <a:pPr indent="0" marL="0">
+            <a:off x="0" y="4937760"/>
+            <a:ext cx="12188952" cy="457200"/>
+          </a:xfrm>
+          <a:prstGeom prst="rect">
+            <a:avLst/>
+          </a:prstGeom>
+          <a:noFill/>
+          <a:ln/>
+        </p:spPr>
+        <p:txBody>
+          <a:bodyPr wrap="square" lIns="0" tIns="0" rIns="0" bIns="0" rtlCol="0" anchor="ctr"/>
+          <a:lstStyle/>
+          <a:p>
+            <a:pPr algn="ctr" indent="0" marL="0">
               <a:buNone/>
             </a:pPr>
             <a:r>
@@ -2045,20 +2017,20 @@
         </p:nvSpPr>
         <p:spPr>
           <a:xfrm>
-            <a:off x="822960" y="5760720"/>
-            <a:ext cx="8229600" cy="365760"/>
-          </a:xfrm>
-          <a:prstGeom prst="rect">
-            <a:avLst/>
-          </a:prstGeom>
-          <a:noFill/>
-          <a:ln/>
-        </p:spPr>
-        <p:txBody>
-          <a:bodyPr wrap="square" lIns="0" tIns="0" rIns="0" bIns="0" rtlCol="0" anchor="ctr"/>
-          <a:lstStyle/>
-          <a:p>
-            <a:pPr indent="0" marL="0">
+            <a:off x="0" y="5669280"/>
+            <a:ext cx="12188952" cy="365760"/>
+          </a:xfrm>
+          <a:prstGeom prst="rect">
+            <a:avLst/>
+          </a:prstGeom>
+          <a:noFill/>
+          <a:ln/>
+        </p:spPr>
+        <p:txBody>
+          <a:bodyPr wrap="square" lIns="0" tIns="0" rIns="0" bIns="0" rtlCol="0" anchor="ctr"/>
+          <a:lstStyle/>
+          <a:p>
+            <a:pPr algn="ctr" indent="0" marL="0">
               <a:buNone/>
             </a:pPr>
             <a:r>
@@ -2116,20 +2088,20 @@
         </p:nvSpPr>
         <p:spPr>
           <a:xfrm>
-            <a:off x="548640" y="384048"/>
-            <a:ext cx="7315200" cy="320040"/>
-          </a:xfrm>
-          <a:prstGeom prst="rect">
-            <a:avLst/>
-          </a:prstGeom>
-          <a:noFill/>
-          <a:ln/>
-        </p:spPr>
-        <p:txBody>
-          <a:bodyPr wrap="square" lIns="0" tIns="0" rIns="0" bIns="0" rtlCol="0" anchor="ctr"/>
-          <a:lstStyle/>
-          <a:p>
-            <a:pPr indent="0" marL="0">
+            <a:off x="0" y="384048"/>
+            <a:ext cx="12188952" cy="320040"/>
+          </a:xfrm>
+          <a:prstGeom prst="rect">
+            <a:avLst/>
+          </a:prstGeom>
+          <a:noFill/>
+          <a:ln/>
+        </p:spPr>
+        <p:txBody>
+          <a:bodyPr wrap="square" lIns="0" tIns="0" rIns="0" bIns="0" rtlCol="0" anchor="ctr"/>
+          <a:lstStyle/>
+          <a:p>
+            <a:pPr algn="ctr" indent="0" marL="0">
               <a:buNone/>
             </a:pPr>
             <a:r>
@@ -2155,8 +2127,8 @@
         </p:nvSpPr>
         <p:spPr>
           <a:xfrm>
-            <a:off x="10634472" y="384048"/>
-            <a:ext cx="1005840" cy="320040"/>
+            <a:off x="11000232" y="384048"/>
+            <a:ext cx="640080" cy="320040"/>
           </a:xfrm>
           <a:prstGeom prst="rect">
             <a:avLst/>
@@ -2172,7 +2144,7 @@
               <a:buNone/>
             </a:pPr>
             <a:r>
-              <a:rPr lang="en-US" sz="1200" b="1" spc="300" kern="0" dirty="0">
+              <a:rPr lang="en-US" sz="1200" b="1" dirty="0">
                 <a:solidFill>
                   <a:srgbClr val="E8C96B"/>
                 </a:solidFill>
@@ -2194,20 +2166,20 @@
         </p:nvSpPr>
         <p:spPr>
           <a:xfrm>
-            <a:off x="822960" y="1554480"/>
-            <a:ext cx="10515600" cy="914400"/>
-          </a:xfrm>
-          <a:prstGeom prst="rect">
-            <a:avLst/>
-          </a:prstGeom>
-          <a:noFill/>
-          <a:ln/>
-        </p:spPr>
-        <p:txBody>
-          <a:bodyPr wrap="square" lIns="0" tIns="0" rIns="0" bIns="0" rtlCol="0" anchor="ctr"/>
-          <a:lstStyle/>
-          <a:p>
-            <a:pPr indent="0" marL="0">
+            <a:off x="0" y="1645920"/>
+            <a:ext cx="12188952" cy="914400"/>
+          </a:xfrm>
+          <a:prstGeom prst="rect">
+            <a:avLst/>
+          </a:prstGeom>
+          <a:noFill/>
+          <a:ln/>
+        </p:spPr>
+        <p:txBody>
+          <a:bodyPr wrap="square" lIns="0" tIns="0" rIns="0" bIns="0" rtlCol="0" anchor="ctr"/>
+          <a:lstStyle/>
+          <a:p>
+            <a:pPr algn="ctr" indent="0" marL="0">
               <a:buNone/>
             </a:pPr>
             <a:r>
@@ -2233,20 +2205,20 @@
         </p:nvSpPr>
         <p:spPr>
           <a:xfrm>
-            <a:off x="822960" y="2468880"/>
-            <a:ext cx="10515600" cy="914400"/>
-          </a:xfrm>
-          <a:prstGeom prst="rect">
-            <a:avLst/>
-          </a:prstGeom>
-          <a:noFill/>
-          <a:ln/>
-        </p:spPr>
-        <p:txBody>
-          <a:bodyPr wrap="square" lIns="0" tIns="0" rIns="0" bIns="0" rtlCol="0" anchor="ctr"/>
-          <a:lstStyle/>
-          <a:p>
-            <a:pPr indent="0" marL="0">
+            <a:off x="0" y="2560320"/>
+            <a:ext cx="12188952" cy="914400"/>
+          </a:xfrm>
+          <a:prstGeom prst="rect">
+            <a:avLst/>
+          </a:prstGeom>
+          <a:noFill/>
+          <a:ln/>
+        </p:spPr>
+        <p:txBody>
+          <a:bodyPr wrap="square" lIns="0" tIns="0" rIns="0" bIns="0" rtlCol="0" anchor="ctr"/>
+          <a:lstStyle/>
+          <a:p>
+            <a:pPr algn="ctr" indent="0" marL="0">
               <a:buNone/>
             </a:pPr>
             <a:r>
@@ -2272,20 +2244,20 @@
         </p:nvSpPr>
         <p:spPr>
           <a:xfrm>
-            <a:off x="822960" y="3657600"/>
-            <a:ext cx="9601200" cy="457200"/>
-          </a:xfrm>
-          <a:prstGeom prst="rect">
-            <a:avLst/>
-          </a:prstGeom>
-          <a:noFill/>
-          <a:ln/>
-        </p:spPr>
-        <p:txBody>
-          <a:bodyPr wrap="square" lIns="0" tIns="0" rIns="0" bIns="0" rtlCol="0" anchor="ctr"/>
-          <a:lstStyle/>
-          <a:p>
-            <a:pPr indent="0" marL="0">
+            <a:off x="0" y="3749040"/>
+            <a:ext cx="12188952" cy="457200"/>
+          </a:xfrm>
+          <a:prstGeom prst="rect">
+            <a:avLst/>
+          </a:prstGeom>
+          <a:noFill/>
+          <a:ln/>
+        </p:spPr>
+        <p:txBody>
+          <a:bodyPr wrap="square" lIns="0" tIns="0" rIns="0" bIns="0" rtlCol="0" anchor="ctr"/>
+          <a:lstStyle/>
+          <a:p>
+            <a:pPr algn="ctr" indent="0" marL="0">
               <a:buNone/>
             </a:pPr>
             <a:r>
@@ -2311,20 +2283,20 @@
         </p:nvSpPr>
         <p:spPr>
           <a:xfrm>
-            <a:off x="822960" y="4663440"/>
-            <a:ext cx="10515600" cy="365760"/>
-          </a:xfrm>
-          <a:prstGeom prst="rect">
-            <a:avLst/>
-          </a:prstGeom>
-          <a:noFill/>
-          <a:ln/>
-        </p:spPr>
-        <p:txBody>
-          <a:bodyPr wrap="square" lIns="0" tIns="0" rIns="0" bIns="0" rtlCol="0" anchor="ctr"/>
-          <a:lstStyle/>
-          <a:p>
-            <a:pPr indent="0" marL="0">
+            <a:off x="0" y="4754880"/>
+            <a:ext cx="12188952" cy="365760"/>
+          </a:xfrm>
+          <a:prstGeom prst="rect">
+            <a:avLst/>
+          </a:prstGeom>
+          <a:noFill/>
+          <a:ln/>
+        </p:spPr>
+        <p:txBody>
+          <a:bodyPr wrap="square" lIns="0" tIns="0" rIns="0" bIns="0" rtlCol="0" anchor="ctr"/>
+          <a:lstStyle/>
+          <a:p>
+            <a:pPr algn="ctr" indent="0" marL="0">
               <a:buNone/>
             </a:pPr>
             <a:r>
@@ -2376,7 +2348,7 @@
       </p:grpSpPr>
       <p:pic>
         <p:nvPicPr>
-          <p:cNvPr id="2" name="Image 0" descr="soa_redacted.png">    </p:cNvPr>
+          <p:cNvPr id="2" name="Image 0" descr="soa_wide.png">    </p:cNvPr>
           <p:cNvPicPr>
             <a:picLocks noChangeAspect="1"/>
           </p:cNvPicPr>
@@ -2390,8 +2362,8 @@
         </p:blipFill>
         <p:spPr>
           <a:xfrm>
-            <a:off x="3668371" y="0"/>
-            <a:ext cx="4852211" cy="6858000"/>
+            <a:off x="3405073" y="411480"/>
+            <a:ext cx="5378806" cy="6309360"/>
           </a:xfrm>
           <a:prstGeom prst="rect">
             <a:avLst/>
@@ -2406,24 +2378,24 @@
         </p:nvSpPr>
         <p:spPr>
           <a:xfrm>
-            <a:off x="320040" y="365760"/>
-            <a:ext cx="3291840" cy="1097280"/>
-          </a:xfrm>
-          <a:prstGeom prst="rect">
-            <a:avLst/>
-          </a:prstGeom>
-          <a:noFill/>
-          <a:ln/>
-        </p:spPr>
-        <p:txBody>
-          <a:bodyPr wrap="square" lIns="0" tIns="0" rIns="0" bIns="0" rtlCol="0" anchor="ctr"/>
-          <a:lstStyle/>
-          <a:p>
-            <a:pPr indent="0" marL="0">
-              <a:buNone/>
-            </a:pPr>
-            <a:r>
-              <a:rPr lang="en-US" sz="1400" b="1" spc="200" kern="0" dirty="0">
+            <a:off x="0" y="164592"/>
+            <a:ext cx="12188952" cy="320040"/>
+          </a:xfrm>
+          <a:prstGeom prst="rect">
+            <a:avLst/>
+          </a:prstGeom>
+          <a:noFill/>
+          <a:ln/>
+        </p:spPr>
+        <p:txBody>
+          <a:bodyPr wrap="square" lIns="0" tIns="0" rIns="0" bIns="0" rtlCol="0" anchor="ctr"/>
+          <a:lstStyle/>
+          <a:p>
+            <a:pPr algn="ctr" indent="0" marL="0">
+              <a:buNone/>
+            </a:pPr>
+            <a:r>
+              <a:rPr lang="en-US" sz="1500" b="1" spc="300" kern="0" dirty="0">
                 <a:solidFill>
                   <a:srgbClr val="E8C96B"/>
                 </a:solidFill>
@@ -2433,7 +2405,7 @@
               </a:rPr>
               <a:t>THE ACTUAL STATEMENT OF ACCOUNT</a:t>
             </a:r>
-            <a:endParaRPr lang="en-US" sz="1400" dirty="0"/>
+            <a:endParaRPr lang="en-US" sz="1500" dirty="0"/>
           </a:p>
         </p:txBody>
       </p:sp>
@@ -2445,7 +2417,7 @@
         </p:nvSpPr>
         <p:spPr>
           <a:xfrm>
-            <a:off x="11274552" y="365760"/>
+            <a:off x="11274552" y="164592"/>
             <a:ext cx="548640" cy="320040"/>
           </a:xfrm>
           <a:prstGeom prst="rect">
@@ -2524,7 +2496,7 @@
         </p:blipFill>
         <p:spPr>
           <a:xfrm>
-            <a:off x="0" y="983076"/>
+            <a:off x="0" y="1165956"/>
             <a:ext cx="12188952" cy="3977447"/>
           </a:xfrm>
           <a:prstGeom prst="rect">
@@ -2540,20 +2512,20 @@
         </p:nvSpPr>
         <p:spPr>
           <a:xfrm>
-            <a:off x="548640" y="457200"/>
-            <a:ext cx="7315200" cy="365760"/>
-          </a:xfrm>
-          <a:prstGeom prst="rect">
-            <a:avLst/>
-          </a:prstGeom>
-          <a:noFill/>
-          <a:ln/>
-        </p:spPr>
-        <p:txBody>
-          <a:bodyPr wrap="square" lIns="0" tIns="0" rIns="0" bIns="0" rtlCol="0" anchor="ctr"/>
-          <a:lstStyle/>
-          <a:p>
-            <a:pPr indent="0" marL="0">
+            <a:off x="0" y="457200"/>
+            <a:ext cx="12188952" cy="365760"/>
+          </a:xfrm>
+          <a:prstGeom prst="rect">
+            <a:avLst/>
+          </a:prstGeom>
+          <a:noFill/>
+          <a:ln/>
+        </p:spPr>
+        <p:txBody>
+          <a:bodyPr wrap="square" lIns="0" tIns="0" rIns="0" bIns="0" rtlCol="0" anchor="ctr"/>
+          <a:lstStyle/>
+          <a:p>
+            <a:pPr algn="ctr" indent="0" marL="0">
               <a:buNone/>
             </a:pPr>
             <a:r>
@@ -2618,20 +2590,20 @@
         </p:nvSpPr>
         <p:spPr>
           <a:xfrm>
-            <a:off x="548640" y="5852160"/>
-            <a:ext cx="11155680" cy="457200"/>
-          </a:xfrm>
-          <a:prstGeom prst="rect">
-            <a:avLst/>
-          </a:prstGeom>
-          <a:noFill/>
-          <a:ln/>
-        </p:spPr>
-        <p:txBody>
-          <a:bodyPr wrap="square" lIns="0" tIns="0" rIns="0" bIns="0" rtlCol="0" anchor="ctr"/>
-          <a:lstStyle/>
-          <a:p>
-            <a:pPr indent="0" marL="0">
+            <a:off x="0" y="5760720"/>
+            <a:ext cx="12188952" cy="457200"/>
+          </a:xfrm>
+          <a:prstGeom prst="rect">
+            <a:avLst/>
+          </a:prstGeom>
+          <a:noFill/>
+          <a:ln/>
+        </p:spPr>
+        <p:txBody>
+          <a:bodyPr wrap="square" lIns="0" tIns="0" rIns="0" bIns="0" rtlCol="0" anchor="ctr"/>
+          <a:lstStyle/>
+          <a:p>
+            <a:pPr algn="ctr" indent="0" marL="0">
               <a:buNone/>
             </a:pPr>
             <a:r>
@@ -2697,7 +2669,7 @@
         </p:blipFill>
         <p:spPr>
           <a:xfrm>
-            <a:off x="0" y="983076"/>
+            <a:off x="0" y="1165956"/>
             <a:ext cx="12188952" cy="3977447"/>
           </a:xfrm>
           <a:prstGeom prst="rect">
@@ -2713,20 +2685,20 @@
         </p:nvSpPr>
         <p:spPr>
           <a:xfrm>
-            <a:off x="548640" y="457200"/>
-            <a:ext cx="7315200" cy="365760"/>
-          </a:xfrm>
-          <a:prstGeom prst="rect">
-            <a:avLst/>
-          </a:prstGeom>
-          <a:noFill/>
-          <a:ln/>
-        </p:spPr>
-        <p:txBody>
-          <a:bodyPr wrap="square" lIns="0" tIns="0" rIns="0" bIns="0" rtlCol="0" anchor="ctr"/>
-          <a:lstStyle/>
-          <a:p>
-            <a:pPr indent="0" marL="0">
+            <a:off x="0" y="457200"/>
+            <a:ext cx="12188952" cy="365760"/>
+          </a:xfrm>
+          <a:prstGeom prst="rect">
+            <a:avLst/>
+          </a:prstGeom>
+          <a:noFill/>
+          <a:ln/>
+        </p:spPr>
+        <p:txBody>
+          <a:bodyPr wrap="square" lIns="0" tIns="0" rIns="0" bIns="0" rtlCol="0" anchor="ctr"/>
+          <a:lstStyle/>
+          <a:p>
+            <a:pPr algn="ctr" indent="0" marL="0">
               <a:buNone/>
             </a:pPr>
             <a:r>
@@ -2791,20 +2763,20 @@
         </p:nvSpPr>
         <p:spPr>
           <a:xfrm>
-            <a:off x="548640" y="5852160"/>
-            <a:ext cx="11155680" cy="457200"/>
-          </a:xfrm>
-          <a:prstGeom prst="rect">
-            <a:avLst/>
-          </a:prstGeom>
-          <a:noFill/>
-          <a:ln/>
-        </p:spPr>
-        <p:txBody>
-          <a:bodyPr wrap="square" lIns="0" tIns="0" rIns="0" bIns="0" rtlCol="0" anchor="ctr"/>
-          <a:lstStyle/>
-          <a:p>
-            <a:pPr indent="0" marL="0">
+            <a:off x="0" y="5760720"/>
+            <a:ext cx="12188952" cy="457200"/>
+          </a:xfrm>
+          <a:prstGeom prst="rect">
+            <a:avLst/>
+          </a:prstGeom>
+          <a:noFill/>
+          <a:ln/>
+        </p:spPr>
+        <p:txBody>
+          <a:bodyPr wrap="square" lIns="0" tIns="0" rIns="0" bIns="0" rtlCol="0" anchor="ctr"/>
+          <a:lstStyle/>
+          <a:p>
+            <a:pPr algn="ctr" indent="0" marL="0">
               <a:buNone/>
             </a:pPr>
             <a:r>
@@ -2862,20 +2834,20 @@
         </p:nvSpPr>
         <p:spPr>
           <a:xfrm>
-            <a:off x="548640" y="384048"/>
-            <a:ext cx="7315200" cy="320040"/>
-          </a:xfrm>
-          <a:prstGeom prst="rect">
-            <a:avLst/>
-          </a:prstGeom>
-          <a:noFill/>
-          <a:ln/>
-        </p:spPr>
-        <p:txBody>
-          <a:bodyPr wrap="square" lIns="0" tIns="0" rIns="0" bIns="0" rtlCol="0" anchor="ctr"/>
-          <a:lstStyle/>
-          <a:p>
-            <a:pPr indent="0" marL="0">
+            <a:off x="0" y="384048"/>
+            <a:ext cx="12188952" cy="320040"/>
+          </a:xfrm>
+          <a:prstGeom prst="rect">
+            <a:avLst/>
+          </a:prstGeom>
+          <a:noFill/>
+          <a:ln/>
+        </p:spPr>
+        <p:txBody>
+          <a:bodyPr wrap="square" lIns="0" tIns="0" rIns="0" bIns="0" rtlCol="0" anchor="ctr"/>
+          <a:lstStyle/>
+          <a:p>
+            <a:pPr algn="ctr" indent="0" marL="0">
               <a:buNone/>
             </a:pPr>
             <a:r>
@@ -2901,8 +2873,8 @@
         </p:nvSpPr>
         <p:spPr>
           <a:xfrm>
-            <a:off x="10634472" y="384048"/>
-            <a:ext cx="1005840" cy="320040"/>
+            <a:off x="11000232" y="384048"/>
+            <a:ext cx="640080" cy="320040"/>
           </a:xfrm>
           <a:prstGeom prst="rect">
             <a:avLst/>
@@ -2918,7 +2890,7 @@
               <a:buNone/>
             </a:pPr>
             <a:r>
-              <a:rPr lang="en-US" sz="1200" b="1" spc="300" kern="0" dirty="0">
+              <a:rPr lang="en-US" sz="1200" b="1" dirty="0">
                 <a:solidFill>
                   <a:srgbClr val="E8C96B"/>
                 </a:solidFill>
@@ -2940,8 +2912,8 @@
         </p:nvSpPr>
         <p:spPr>
           <a:xfrm>
-            <a:off x="822960" y="1554480"/>
-            <a:ext cx="4206240" cy="365760"/>
+            <a:off x="822960" y="1463040"/>
+            <a:ext cx="4389120" cy="365760"/>
           </a:xfrm>
           <a:prstGeom prst="rect">
             <a:avLst/>
@@ -2979,8 +2951,8 @@
         </p:nvSpPr>
         <p:spPr>
           <a:xfrm>
-            <a:off x="822960" y="1901952"/>
-            <a:ext cx="4206240" cy="502920"/>
+            <a:off x="822960" y="1810512"/>
+            <a:ext cx="4389120" cy="502920"/>
           </a:xfrm>
           <a:prstGeom prst="rect">
             <a:avLst/>
@@ -3018,8 +2990,8 @@
         </p:nvSpPr>
         <p:spPr>
           <a:xfrm>
-            <a:off x="822960" y="2606040"/>
-            <a:ext cx="4206240" cy="365760"/>
+            <a:off x="822960" y="2514600"/>
+            <a:ext cx="4389120" cy="365760"/>
           </a:xfrm>
           <a:prstGeom prst="rect">
             <a:avLst/>
@@ -3057,8 +3029,8 @@
         </p:nvSpPr>
         <p:spPr>
           <a:xfrm>
-            <a:off x="822960" y="2953512"/>
-            <a:ext cx="4206240" cy="502920"/>
+            <a:off x="822960" y="2862072"/>
+            <a:ext cx="4389120" cy="502920"/>
           </a:xfrm>
           <a:prstGeom prst="rect">
             <a:avLst/>
@@ -3096,8 +3068,8 @@
         </p:nvSpPr>
         <p:spPr>
           <a:xfrm>
-            <a:off x="822960" y="3657600"/>
-            <a:ext cx="4206240" cy="365760"/>
+            <a:off x="822960" y="3566160"/>
+            <a:ext cx="4389120" cy="365760"/>
           </a:xfrm>
           <a:prstGeom prst="rect">
             <a:avLst/>
@@ -3135,8 +3107,8 @@
         </p:nvSpPr>
         <p:spPr>
           <a:xfrm>
-            <a:off x="822960" y="4005072"/>
-            <a:ext cx="4206240" cy="502920"/>
+            <a:off x="822960" y="3913632"/>
+            <a:ext cx="4389120" cy="502920"/>
           </a:xfrm>
           <a:prstGeom prst="rect">
             <a:avLst/>
@@ -3174,8 +3146,8 @@
         </p:nvSpPr>
         <p:spPr>
           <a:xfrm>
-            <a:off x="822960" y="4709160"/>
-            <a:ext cx="4206240" cy="365760"/>
+            <a:off x="822960" y="4617720"/>
+            <a:ext cx="4389120" cy="365760"/>
           </a:xfrm>
           <a:prstGeom prst="rect">
             <a:avLst/>
@@ -3213,8 +3185,8 @@
         </p:nvSpPr>
         <p:spPr>
           <a:xfrm>
-            <a:off x="822960" y="5056632"/>
-            <a:ext cx="4206240" cy="502920"/>
+            <a:off x="822960" y="4965192"/>
+            <a:ext cx="4389120" cy="502920"/>
           </a:xfrm>
           <a:prstGeom prst="rect">
             <a:avLst/>
@@ -3252,7 +3224,7 @@
         </p:nvSpPr>
         <p:spPr>
           <a:xfrm>
-            <a:off x="6035040" y="1417320"/>
+            <a:off x="6126480" y="1417320"/>
             <a:ext cx="5303520" cy="320040"/>
           </a:xfrm>
           <a:prstGeom prst="rect">
@@ -3291,7 +3263,7 @@
         </p:nvSpPr>
         <p:spPr>
           <a:xfrm>
-            <a:off x="6035040" y="1737360"/>
+            <a:off x="6126480" y="1737360"/>
             <a:ext cx="5669280" cy="914400"/>
           </a:xfrm>
           <a:prstGeom prst="rect">
@@ -3308,7 +3280,7 @@
               <a:buNone/>
             </a:pPr>
             <a:r>
-              <a:rPr lang="en-US" sz="5400" b="1" dirty="0">
+              <a:rPr lang="en-US" sz="5000" b="1" dirty="0">
                 <a:solidFill>
                   <a:srgbClr val="E8C96B"/>
                 </a:solidFill>
@@ -3316,9 +3288,9 @@
                 <a:ea typeface="Palatino Linotype" pitchFamily="34" charset="-122"/>
                 <a:cs typeface="Palatino Linotype" pitchFamily="34" charset="-120"/>
               </a:rPr>
-              <a:t>44%</a:t>
-            </a:r>
-            <a:endParaRPr lang="en-US" sz="5400" dirty="0"/>
+              <a:t>+Đ819,440</a:t>
+            </a:r>
+            <a:endParaRPr lang="en-US" sz="5000" dirty="0"/>
           </a:p>
         </p:txBody>
       </p:sp>
@@ -3330,8 +3302,8 @@
         </p:nvSpPr>
         <p:spPr>
           <a:xfrm>
-            <a:off x="6035040" y="3108960"/>
-            <a:ext cx="3108960" cy="457200"/>
+            <a:off x="6126480" y="3200400"/>
+            <a:ext cx="3017520" cy="457200"/>
           </a:xfrm>
           <a:prstGeom prst="rect">
             <a:avLst/>
@@ -3369,8 +3341,8 @@
         </p:nvSpPr>
         <p:spPr>
           <a:xfrm>
-            <a:off x="9235440" y="3035808"/>
-            <a:ext cx="2377440" cy="548640"/>
+            <a:off x="9144000" y="3108960"/>
+            <a:ext cx="2468880" cy="548640"/>
           </a:xfrm>
           <a:prstGeom prst="rect">
             <a:avLst/>
@@ -3394,7 +3366,7 @@
                 <a:ea typeface="Palatino Linotype" pitchFamily="34" charset="-122"/>
                 <a:cs typeface="Palatino Linotype" pitchFamily="34" charset="-120"/>
               </a:rPr>
-              <a:t>85%</a:t>
+              <a:t>44%</a:t>
             </a:r>
             <a:endParaRPr lang="en-US" sz="3000" dirty="0"/>
           </a:p>
@@ -3408,8 +3380,8 @@
         </p:nvSpPr>
         <p:spPr>
           <a:xfrm>
-            <a:off x="6035040" y="3977640"/>
-            <a:ext cx="3108960" cy="457200"/>
+            <a:off x="6126480" y="4069080"/>
+            <a:ext cx="3017520" cy="457200"/>
           </a:xfrm>
           <a:prstGeom prst="rect">
             <a:avLst/>
@@ -3447,8 +3419,8 @@
         </p:nvSpPr>
         <p:spPr>
           <a:xfrm>
-            <a:off x="9235440" y="3904488"/>
-            <a:ext cx="2377440" cy="548640"/>
+            <a:off x="9144000" y="3977640"/>
+            <a:ext cx="2468880" cy="548640"/>
           </a:xfrm>
           <a:prstGeom prst="rect">
             <a:avLst/>
@@ -3472,7 +3444,7 @@
                 <a:ea typeface="Palatino Linotype" pitchFamily="34" charset="-122"/>
                 <a:cs typeface="Palatino Linotype" pitchFamily="34" charset="-120"/>
               </a:rPr>
-              <a:t>17.8%</a:t>
+              <a:t>85%</a:t>
             </a:r>
             <a:endParaRPr lang="en-US" sz="3000" dirty="0"/>
           </a:p>
@@ -3486,8 +3458,8 @@
         </p:nvSpPr>
         <p:spPr>
           <a:xfrm>
-            <a:off x="6035040" y="4846320"/>
-            <a:ext cx="3108960" cy="457200"/>
+            <a:off x="6126480" y="4937760"/>
+            <a:ext cx="3017520" cy="457200"/>
           </a:xfrm>
           <a:prstGeom prst="rect">
             <a:avLst/>
@@ -3525,8 +3497,8 @@
         </p:nvSpPr>
         <p:spPr>
           <a:xfrm>
-            <a:off x="9235440" y="4773168"/>
-            <a:ext cx="2377440" cy="548640"/>
+            <a:off x="9144000" y="4846320"/>
+            <a:ext cx="2468880" cy="548640"/>
           </a:xfrm>
           <a:prstGeom prst="rect">
             <a:avLst/>
@@ -3541,6 +3513,17 @@
             <a:pPr indent="0" marL="0">
               <a:buNone/>
             </a:pPr>
+            <a:r>
+              <a:rPr lang="en-US" sz="3000" b="1" dirty="0">
+                <a:solidFill>
+                  <a:srgbClr val="F5EDE0"/>
+                </a:solidFill>
+                <a:latin typeface="Palatino Linotype" pitchFamily="34" charset="0"/>
+                <a:ea typeface="Palatino Linotype" pitchFamily="34" charset="-122"/>
+                <a:cs typeface="Palatino Linotype" pitchFamily="34" charset="-120"/>
+              </a:rPr>
+              <a:t>17.8%</a:t>
+            </a:r>
             <a:endParaRPr lang="en-US" sz="3000" dirty="0"/>
           </a:p>
         </p:txBody>
@@ -3553,20 +3536,20 @@
         </p:nvSpPr>
         <p:spPr>
           <a:xfrm>
-            <a:off x="822960" y="5943600"/>
-            <a:ext cx="10515600" cy="411480"/>
-          </a:xfrm>
-          <a:prstGeom prst="rect">
-            <a:avLst/>
-          </a:prstGeom>
-          <a:noFill/>
-          <a:ln/>
-        </p:spPr>
-        <p:txBody>
-          <a:bodyPr wrap="square" lIns="0" tIns="0" rIns="0" bIns="0" rtlCol="0" anchor="ctr"/>
-          <a:lstStyle/>
-          <a:p>
-            <a:pPr indent="0" marL="0">
+            <a:off x="0" y="6035040"/>
+            <a:ext cx="12188952" cy="411480"/>
+          </a:xfrm>
+          <a:prstGeom prst="rect">
+            <a:avLst/>
+          </a:prstGeom>
+          <a:noFill/>
+          <a:ln/>
+        </p:spPr>
+        <p:txBody>
+          <a:bodyPr wrap="square" lIns="0" tIns="0" rIns="0" bIns="0" rtlCol="0" anchor="ctr"/>
+          <a:lstStyle/>
+          <a:p>
+            <a:pPr algn="ctr" indent="0" marL="0">
               <a:buNone/>
             </a:pPr>
             <a:r>
@@ -3624,20 +3607,20 @@
         </p:nvSpPr>
         <p:spPr>
           <a:xfrm>
-            <a:off x="548640" y="384048"/>
-            <a:ext cx="7315200" cy="320040"/>
-          </a:xfrm>
-          <a:prstGeom prst="rect">
-            <a:avLst/>
-          </a:prstGeom>
-          <a:noFill/>
-          <a:ln/>
-        </p:spPr>
-        <p:txBody>
-          <a:bodyPr wrap="square" lIns="0" tIns="0" rIns="0" bIns="0" rtlCol="0" anchor="ctr"/>
-          <a:lstStyle/>
-          <a:p>
-            <a:pPr indent="0" marL="0">
+            <a:off x="0" y="384048"/>
+            <a:ext cx="12188952" cy="320040"/>
+          </a:xfrm>
+          <a:prstGeom prst="rect">
+            <a:avLst/>
+          </a:prstGeom>
+          <a:noFill/>
+          <a:ln/>
+        </p:spPr>
+        <p:txBody>
+          <a:bodyPr wrap="square" lIns="0" tIns="0" rIns="0" bIns="0" rtlCol="0" anchor="ctr"/>
+          <a:lstStyle/>
+          <a:p>
+            <a:pPr algn="ctr" indent="0" marL="0">
               <a:buNone/>
             </a:pPr>
             <a:r>
@@ -3663,8 +3646,8 @@
         </p:nvSpPr>
         <p:spPr>
           <a:xfrm>
-            <a:off x="10634472" y="384048"/>
-            <a:ext cx="1005840" cy="320040"/>
+            <a:off x="11000232" y="384048"/>
+            <a:ext cx="640080" cy="320040"/>
           </a:xfrm>
           <a:prstGeom prst="rect">
             <a:avLst/>
@@ -3680,7 +3663,7 @@
               <a:buNone/>
             </a:pPr>
             <a:r>
-              <a:rPr lang="en-US" sz="1200" b="1" spc="300" kern="0" dirty="0">
+              <a:rPr lang="en-US" sz="1200" b="1" dirty="0">
                 <a:solidFill>
                   <a:srgbClr val="E8C96B"/>
                 </a:solidFill>
@@ -3702,8 +3685,8 @@
         </p:nvSpPr>
         <p:spPr>
           <a:xfrm>
-            <a:off x="822960" y="1554480"/>
-            <a:ext cx="4206240" cy="365760"/>
+            <a:off x="822960" y="1463040"/>
+            <a:ext cx="4389120" cy="365760"/>
           </a:xfrm>
           <a:prstGeom prst="rect">
             <a:avLst/>
@@ -3741,8 +3724,8 @@
         </p:nvSpPr>
         <p:spPr>
           <a:xfrm>
-            <a:off x="822960" y="1901952"/>
-            <a:ext cx="4206240" cy="502920"/>
+            <a:off x="822960" y="1810512"/>
+            <a:ext cx="4389120" cy="502920"/>
           </a:xfrm>
           <a:prstGeom prst="rect">
             <a:avLst/>
@@ -3780,8 +3763,8 @@
         </p:nvSpPr>
         <p:spPr>
           <a:xfrm>
-            <a:off x="822960" y="2606040"/>
-            <a:ext cx="4206240" cy="365760"/>
+            <a:off x="822960" y="2514600"/>
+            <a:ext cx="4389120" cy="365760"/>
           </a:xfrm>
           <a:prstGeom prst="rect">
             <a:avLst/>
@@ -3819,8 +3802,8 @@
         </p:nvSpPr>
         <p:spPr>
           <a:xfrm>
-            <a:off x="822960" y="2953512"/>
-            <a:ext cx="4206240" cy="502920"/>
+            <a:off x="822960" y="2862072"/>
+            <a:ext cx="4389120" cy="502920"/>
           </a:xfrm>
           <a:prstGeom prst="rect">
             <a:avLst/>
@@ -3858,8 +3841,8 @@
         </p:nvSpPr>
         <p:spPr>
           <a:xfrm>
-            <a:off x="822960" y="3657600"/>
-            <a:ext cx="4206240" cy="365760"/>
+            <a:off x="822960" y="3566160"/>
+            <a:ext cx="4389120" cy="365760"/>
           </a:xfrm>
           <a:prstGeom prst="rect">
             <a:avLst/>
@@ -3897,8 +3880,8 @@
         </p:nvSpPr>
         <p:spPr>
           <a:xfrm>
-            <a:off x="822960" y="4005072"/>
-            <a:ext cx="4206240" cy="502920"/>
+            <a:off x="822960" y="3913632"/>
+            <a:ext cx="4389120" cy="502920"/>
           </a:xfrm>
           <a:prstGeom prst="rect">
             <a:avLst/>
@@ -3936,8 +3919,8 @@
         </p:nvSpPr>
         <p:spPr>
           <a:xfrm>
-            <a:off x="822960" y="4709160"/>
-            <a:ext cx="4206240" cy="365760"/>
+            <a:off x="822960" y="4617720"/>
+            <a:ext cx="4389120" cy="365760"/>
           </a:xfrm>
           <a:prstGeom prst="rect">
             <a:avLst/>
@@ -3975,8 +3958,8 @@
         </p:nvSpPr>
         <p:spPr>
           <a:xfrm>
-            <a:off x="822960" y="5056632"/>
-            <a:ext cx="4206240" cy="502920"/>
+            <a:off x="822960" y="4965192"/>
+            <a:ext cx="4389120" cy="502920"/>
           </a:xfrm>
           <a:prstGeom prst="rect">
             <a:avLst/>
@@ -4014,7 +3997,7 @@
         </p:nvSpPr>
         <p:spPr>
           <a:xfrm>
-            <a:off x="6035040" y="1417320"/>
+            <a:off x="6126480" y="1417320"/>
             <a:ext cx="5303520" cy="320040"/>
           </a:xfrm>
           <a:prstGeom prst="rect">
@@ -4053,7 +4036,7 @@
         </p:nvSpPr>
         <p:spPr>
           <a:xfrm>
-            <a:off x="6035040" y="1737360"/>
+            <a:off x="6126480" y="1737360"/>
             <a:ext cx="5669280" cy="914400"/>
           </a:xfrm>
           <a:prstGeom prst="rect">
@@ -4070,7 +4053,7 @@
               <a:buNone/>
             </a:pPr>
             <a:r>
-              <a:rPr lang="en-US" sz="5400" b="1" dirty="0">
+              <a:rPr lang="en-US" sz="5000" b="1" dirty="0">
                 <a:solidFill>
                   <a:srgbClr val="E8C96B"/>
                 </a:solidFill>
@@ -4078,9 +4061,9 @@
                 <a:ea typeface="Palatino Linotype" pitchFamily="34" charset="-122"/>
                 <a:cs typeface="Palatino Linotype" pitchFamily="34" charset="-120"/>
               </a:rPr>
-              <a:t>59%</a:t>
-            </a:r>
-            <a:endParaRPr lang="en-US" sz="5400" dirty="0"/>
+              <a:t>+Đ1,101,940</a:t>
+            </a:r>
+            <a:endParaRPr lang="en-US" sz="5000" dirty="0"/>
           </a:p>
         </p:txBody>
       </p:sp>
@@ -4092,8 +4075,8 @@
         </p:nvSpPr>
         <p:spPr>
           <a:xfrm>
-            <a:off x="6035040" y="3108960"/>
-            <a:ext cx="3108960" cy="457200"/>
+            <a:off x="6126480" y="3200400"/>
+            <a:ext cx="3017520" cy="457200"/>
           </a:xfrm>
           <a:prstGeom prst="rect">
             <a:avLst/>
@@ -4131,8 +4114,8 @@
         </p:nvSpPr>
         <p:spPr>
           <a:xfrm>
-            <a:off x="9235440" y="3035808"/>
-            <a:ext cx="2377440" cy="548640"/>
+            <a:off x="9144000" y="3108960"/>
+            <a:ext cx="2468880" cy="548640"/>
           </a:xfrm>
           <a:prstGeom prst="rect">
             <a:avLst/>
@@ -4156,7 +4139,7 @@
                 <a:ea typeface="Palatino Linotype" pitchFamily="34" charset="-122"/>
                 <a:cs typeface="Palatino Linotype" pitchFamily="34" charset="-120"/>
               </a:rPr>
-              <a:t>114%</a:t>
+              <a:t>59%</a:t>
             </a:r>
             <a:endParaRPr lang="en-US" sz="3000" dirty="0"/>
           </a:p>
@@ -4170,8 +4153,8 @@
         </p:nvSpPr>
         <p:spPr>
           <a:xfrm>
-            <a:off x="6035040" y="3977640"/>
-            <a:ext cx="3108960" cy="457200"/>
+            <a:off x="6126480" y="4069080"/>
+            <a:ext cx="3017520" cy="457200"/>
           </a:xfrm>
           <a:prstGeom prst="rect">
             <a:avLst/>
@@ -4209,8 +4192,8 @@
         </p:nvSpPr>
         <p:spPr>
           <a:xfrm>
-            <a:off x="9235440" y="3904488"/>
-            <a:ext cx="2377440" cy="548640"/>
+            <a:off x="9144000" y="3977640"/>
+            <a:ext cx="2468880" cy="548640"/>
           </a:xfrm>
           <a:prstGeom prst="rect">
             <a:avLst/>
@@ -4234,7 +4217,7 @@
                 <a:ea typeface="Palatino Linotype" pitchFamily="34" charset="-122"/>
                 <a:cs typeface="Palatino Linotype" pitchFamily="34" charset="-120"/>
               </a:rPr>
-              <a:t>22.4%</a:t>
+              <a:t>114%</a:t>
             </a:r>
             <a:endParaRPr lang="en-US" sz="3000" dirty="0"/>
           </a:p>
@@ -4248,8 +4231,8 @@
         </p:nvSpPr>
         <p:spPr>
           <a:xfrm>
-            <a:off x="6035040" y="4846320"/>
-            <a:ext cx="3108960" cy="457200"/>
+            <a:off x="6126480" y="4937760"/>
+            <a:ext cx="3017520" cy="457200"/>
           </a:xfrm>
           <a:prstGeom prst="rect">
             <a:avLst/>
@@ -4287,8 +4270,8 @@
         </p:nvSpPr>
         <p:spPr>
           <a:xfrm>
-            <a:off x="9235440" y="4773168"/>
-            <a:ext cx="2377440" cy="548640"/>
+            <a:off x="9144000" y="4846320"/>
+            <a:ext cx="2468880" cy="548640"/>
           </a:xfrm>
           <a:prstGeom prst="rect">
             <a:avLst/>
@@ -4303,6 +4286,17 @@
             <a:pPr indent="0" marL="0">
               <a:buNone/>
             </a:pPr>
+            <a:r>
+              <a:rPr lang="en-US" sz="3000" b="1" dirty="0">
+                <a:solidFill>
+                  <a:srgbClr val="F5EDE0"/>
+                </a:solidFill>
+                <a:latin typeface="Palatino Linotype" pitchFamily="34" charset="0"/>
+                <a:ea typeface="Palatino Linotype" pitchFamily="34" charset="-122"/>
+                <a:cs typeface="Palatino Linotype" pitchFamily="34" charset="-120"/>
+              </a:rPr>
+              <a:t>22.4%</a:t>
+            </a:r>
             <a:endParaRPr lang="en-US" sz="3000" dirty="0"/>
           </a:p>
         </p:txBody>
@@ -4315,20 +4309,20 @@
         </p:nvSpPr>
         <p:spPr>
           <a:xfrm>
-            <a:off x="822960" y="5943600"/>
-            <a:ext cx="10698480" cy="411480"/>
-          </a:xfrm>
-          <a:prstGeom prst="rect">
-            <a:avLst/>
-          </a:prstGeom>
-          <a:noFill/>
-          <a:ln/>
-        </p:spPr>
-        <p:txBody>
-          <a:bodyPr wrap="square" lIns="0" tIns="0" rIns="0" bIns="0" rtlCol="0" anchor="ctr"/>
-          <a:lstStyle/>
-          <a:p>
-            <a:pPr indent="0" marL="0">
+            <a:off x="0" y="6035040"/>
+            <a:ext cx="12188952" cy="411480"/>
+          </a:xfrm>
+          <a:prstGeom prst="rect">
+            <a:avLst/>
+          </a:prstGeom>
+          <a:noFill/>
+          <a:ln/>
+        </p:spPr>
+        <p:txBody>
+          <a:bodyPr wrap="square" lIns="0" tIns="0" rIns="0" bIns="0" rtlCol="0" anchor="ctr"/>
+          <a:lstStyle/>
+          <a:p>
+            <a:pPr algn="ctr" indent="0" marL="0">
               <a:buNone/>
             </a:pPr>
             <a:r>
@@ -4386,20 +4380,20 @@
         </p:nvSpPr>
         <p:spPr>
           <a:xfrm>
-            <a:off x="548640" y="384048"/>
-            <a:ext cx="7315200" cy="320040"/>
-          </a:xfrm>
-          <a:prstGeom prst="rect">
-            <a:avLst/>
-          </a:prstGeom>
-          <a:noFill/>
-          <a:ln/>
-        </p:spPr>
-        <p:txBody>
-          <a:bodyPr wrap="square" lIns="0" tIns="0" rIns="0" bIns="0" rtlCol="0" anchor="ctr"/>
-          <a:lstStyle/>
-          <a:p>
-            <a:pPr indent="0" marL="0">
+            <a:off x="0" y="384048"/>
+            <a:ext cx="12188952" cy="320040"/>
+          </a:xfrm>
+          <a:prstGeom prst="rect">
+            <a:avLst/>
+          </a:prstGeom>
+          <a:noFill/>
+          <a:ln/>
+        </p:spPr>
+        <p:txBody>
+          <a:bodyPr wrap="square" lIns="0" tIns="0" rIns="0" bIns="0" rtlCol="0" anchor="ctr"/>
+          <a:lstStyle/>
+          <a:p>
+            <a:pPr algn="ctr" indent="0" marL="0">
               <a:buNone/>
             </a:pPr>
             <a:r>
@@ -4425,8 +4419,8 @@
         </p:nvSpPr>
         <p:spPr>
           <a:xfrm>
-            <a:off x="10634472" y="384048"/>
-            <a:ext cx="1005840" cy="320040"/>
+            <a:off x="11000232" y="384048"/>
+            <a:ext cx="640080" cy="320040"/>
           </a:xfrm>
           <a:prstGeom prst="rect">
             <a:avLst/>
@@ -4442,7 +4436,7 @@
               <a:buNone/>
             </a:pPr>
             <a:r>
-              <a:rPr lang="en-US" sz="1200" b="1" spc="300" kern="0" dirty="0">
+              <a:rPr lang="en-US" sz="1200" b="1" dirty="0">
                 <a:solidFill>
                   <a:srgbClr val="E8C96B"/>
                 </a:solidFill>
@@ -4464,20 +4458,20 @@
         </p:nvSpPr>
         <p:spPr>
           <a:xfrm>
-            <a:off x="822960" y="1737360"/>
-            <a:ext cx="10515600" cy="822960"/>
-          </a:xfrm>
-          <a:prstGeom prst="rect">
-            <a:avLst/>
-          </a:prstGeom>
-          <a:noFill/>
-          <a:ln/>
-        </p:spPr>
-        <p:txBody>
-          <a:bodyPr wrap="square" lIns="0" tIns="0" rIns="0" bIns="0" rtlCol="0" anchor="ctr"/>
-          <a:lstStyle/>
-          <a:p>
-            <a:pPr indent="0" marL="0">
+            <a:off x="0" y="1828800"/>
+            <a:ext cx="12188952" cy="822960"/>
+          </a:xfrm>
+          <a:prstGeom prst="rect">
+            <a:avLst/>
+          </a:prstGeom>
+          <a:noFill/>
+          <a:ln/>
+        </p:spPr>
+        <p:txBody>
+          <a:bodyPr wrap="square" lIns="0" tIns="0" rIns="0" bIns="0" rtlCol="0" anchor="ctr"/>
+          <a:lstStyle/>
+          <a:p>
+            <a:pPr algn="ctr" indent="0" marL="0">
               <a:buNone/>
             </a:pPr>
             <a:r>
@@ -4503,20 +4497,20 @@
         </p:nvSpPr>
         <p:spPr>
           <a:xfrm>
-            <a:off x="822960" y="2651760"/>
-            <a:ext cx="10515600" cy="822960"/>
-          </a:xfrm>
-          <a:prstGeom prst="rect">
-            <a:avLst/>
-          </a:prstGeom>
-          <a:noFill/>
-          <a:ln/>
-        </p:spPr>
-        <p:txBody>
-          <a:bodyPr wrap="square" lIns="0" tIns="0" rIns="0" bIns="0" rtlCol="0" anchor="ctr"/>
-          <a:lstStyle/>
-          <a:p>
-            <a:pPr indent="0" marL="0">
+            <a:off x="0" y="2743200"/>
+            <a:ext cx="12188952" cy="822960"/>
+          </a:xfrm>
+          <a:prstGeom prst="rect">
+            <a:avLst/>
+          </a:prstGeom>
+          <a:noFill/>
+          <a:ln/>
+        </p:spPr>
+        <p:txBody>
+          <a:bodyPr wrap="square" lIns="0" tIns="0" rIns="0" bIns="0" rtlCol="0" anchor="ctr"/>
+          <a:lstStyle/>
+          <a:p>
+            <a:pPr algn="ctr" indent="0" marL="0">
               <a:buNone/>
             </a:pPr>
             <a:r>
@@ -4542,20 +4536,20 @@
         </p:nvSpPr>
         <p:spPr>
           <a:xfrm>
-            <a:off x="822960" y="3931920"/>
-            <a:ext cx="9144000" cy="457200"/>
-          </a:xfrm>
-          <a:prstGeom prst="rect">
-            <a:avLst/>
-          </a:prstGeom>
-          <a:noFill/>
-          <a:ln/>
-        </p:spPr>
-        <p:txBody>
-          <a:bodyPr wrap="square" lIns="0" tIns="0" rIns="0" bIns="0" rtlCol="0" anchor="ctr"/>
-          <a:lstStyle/>
-          <a:p>
-            <a:pPr indent="0" marL="0">
+            <a:off x="0" y="4023360"/>
+            <a:ext cx="12188952" cy="457200"/>
+          </a:xfrm>
+          <a:prstGeom prst="rect">
+            <a:avLst/>
+          </a:prstGeom>
+          <a:noFill/>
+          <a:ln/>
+        </p:spPr>
+        <p:txBody>
+          <a:bodyPr wrap="square" lIns="0" tIns="0" rIns="0" bIns="0" rtlCol="0" anchor="ctr"/>
+          <a:lstStyle/>
+          <a:p>
+            <a:pPr algn="ctr" indent="0" marL="0">
               <a:buNone/>
             </a:pPr>
             <a:r>
@@ -4581,20 +4575,20 @@
         </p:nvSpPr>
         <p:spPr>
           <a:xfrm>
-            <a:off x="822960" y="4846320"/>
-            <a:ext cx="10515600" cy="365760"/>
-          </a:xfrm>
-          <a:prstGeom prst="rect">
-            <a:avLst/>
-          </a:prstGeom>
-          <a:noFill/>
-          <a:ln/>
-        </p:spPr>
-        <p:txBody>
-          <a:bodyPr wrap="square" lIns="0" tIns="0" rIns="0" bIns="0" rtlCol="0" anchor="ctr"/>
-          <a:lstStyle/>
-          <a:p>
-            <a:pPr indent="0" marL="0">
+            <a:off x="0" y="4937760"/>
+            <a:ext cx="12188952" cy="365760"/>
+          </a:xfrm>
+          <a:prstGeom prst="rect">
+            <a:avLst/>
+          </a:prstGeom>
+          <a:noFill/>
+          <a:ln/>
+        </p:spPr>
+        <p:txBody>
+          <a:bodyPr wrap="square" lIns="0" tIns="0" rIns="0" bIns="0" rtlCol="0" anchor="ctr"/>
+          <a:lstStyle/>
+          <a:p>
+            <a:pPr algn="ctr" indent="0" marL="0">
               <a:buNone/>
             </a:pPr>
             <a:r>
@@ -4620,20 +4614,20 @@
         </p:nvSpPr>
         <p:spPr>
           <a:xfrm>
-            <a:off x="822960" y="6126480"/>
-            <a:ext cx="5486400" cy="365760"/>
-          </a:xfrm>
-          <a:prstGeom prst="rect">
-            <a:avLst/>
-          </a:prstGeom>
-          <a:noFill/>
-          <a:ln/>
-        </p:spPr>
-        <p:txBody>
-          <a:bodyPr wrap="square" lIns="0" tIns="0" rIns="0" bIns="0" rtlCol="0" anchor="ctr"/>
-          <a:lstStyle/>
-          <a:p>
-            <a:pPr indent="0" marL="0">
+            <a:off x="0" y="6126480"/>
+            <a:ext cx="12188952" cy="365760"/>
+          </a:xfrm>
+          <a:prstGeom prst="rect">
+            <a:avLst/>
+          </a:prstGeom>
+          <a:noFill/>
+          <a:ln/>
+        </p:spPr>
+        <p:txBody>
+          <a:bodyPr wrap="square" lIns="0" tIns="0" rIns="0" bIns="0" rtlCol="0" anchor="ctr"/>
+          <a:lstStyle/>
+          <a:p>
+            <a:pPr algn="ctr" indent="0" marL="0">
               <a:buNone/>
             </a:pPr>
             <a:r>

</xml_diff>

<commit_message>
EP1 v3: cover line, unstretched house, series title only, full-width SOA
</commit_message>
<xml_diff>
--- a/content-assets/lagoons-ep1/lagoons-review-ep1.pptx
+++ b/content-assets/lagoons-ep1/lagoons-review-ep1.pptx
@@ -1698,7 +1698,7 @@
                 <a:ea typeface="Palatino Linotype" pitchFamily="34" charset="-122"/>
                 <a:cs typeface="Palatino Linotype" pitchFamily="34" charset="-120"/>
               </a:rPr>
-              <a:t>I pulled the receipts.</a:t>
+              <a:t>Let’s see if they come true.</a:t>
             </a:r>
             <a:endParaRPr lang="en-US" sz="5400" dirty="0"/>
           </a:p>
@@ -1809,7 +1809,7 @@
       </p:grpSpPr>
       <p:pic>
         <p:nvPicPr>
-          <p:cNvPr id="2" name="Image 0" descr="house.jpg">    </p:cNvPr>
+          <p:cNvPr id="2" name="Image 0" descr="house169.jpg">    </p:cNvPr>
           <p:cNvPicPr>
             <a:picLocks noChangeAspect="1"/>
           </p:cNvPicPr>
@@ -2166,7 +2166,7 @@
         </p:nvSpPr>
         <p:spPr>
           <a:xfrm>
-            <a:off x="0" y="1645920"/>
+            <a:off x="0" y="2377440"/>
             <a:ext cx="12188952" cy="914400"/>
           </a:xfrm>
           <a:prstGeom prst="rect">
@@ -2205,7 +2205,7 @@
         </p:nvSpPr>
         <p:spPr>
           <a:xfrm>
-            <a:off x="0" y="2560320"/>
+            <a:off x="0" y="3291840"/>
             <a:ext cx="12188952" cy="914400"/>
           </a:xfrm>
           <a:prstGeom prst="rect">
@@ -2233,84 +2233,6 @@
               <a:t>&amp; the Ugly.</a:t>
             </a:r>
             <a:endParaRPr lang="en-US" sz="5200" dirty="0"/>
-          </a:p>
-        </p:txBody>
-      </p:sp>
-      <p:sp>
-        <p:nvSpPr>
-          <p:cNvPr id="6" name="Text 4"/>
-          <p:cNvSpPr/>
-          <p:nvPr/>
-        </p:nvSpPr>
-        <p:spPr>
-          <a:xfrm>
-            <a:off x="0" y="3749040"/>
-            <a:ext cx="12188952" cy="457200"/>
-          </a:xfrm>
-          <a:prstGeom prst="rect">
-            <a:avLst/>
-          </a:prstGeom>
-          <a:noFill/>
-          <a:ln/>
-        </p:spPr>
-        <p:txBody>
-          <a:bodyPr wrap="square" lIns="0" tIns="0" rIns="0" bIns="0" rtlCol="0" anchor="ctr"/>
-          <a:lstStyle/>
-          <a:p>
-            <a:pPr algn="ctr" indent="0" marL="0">
-              <a:buNone/>
-            </a:pPr>
-            <a:r>
-              <a:rPr lang="en-US" sz="2200" dirty="0">
-                <a:solidFill>
-                  <a:srgbClr val="F5EDE0"/>
-                </a:solidFill>
-                <a:latin typeface="Palatino Linotype" pitchFamily="34" charset="0"/>
-                <a:ea typeface="Palatino Linotype" pitchFamily="34" charset="-122"/>
-                <a:cs typeface="Palatino Linotype" pitchFamily="34" charset="-120"/>
-              </a:rPr>
-              <a:t>Handed-over projects, marked to market. No projections - title deeds.</a:t>
-            </a:r>
-            <a:endParaRPr lang="en-US" sz="2200" dirty="0"/>
-          </a:p>
-        </p:txBody>
-      </p:sp>
-      <p:sp>
-        <p:nvSpPr>
-          <p:cNvPr id="7" name="Text 5"/>
-          <p:cNvSpPr/>
-          <p:nvPr/>
-        </p:nvSpPr>
-        <p:spPr>
-          <a:xfrm>
-            <a:off x="0" y="4754880"/>
-            <a:ext cx="12188952" cy="365760"/>
-          </a:xfrm>
-          <a:prstGeom prst="rect">
-            <a:avLst/>
-          </a:prstGeom>
-          <a:noFill/>
-          <a:ln/>
-        </p:spPr>
-        <p:txBody>
-          <a:bodyPr wrap="square" lIns="0" tIns="0" rIns="0" bIns="0" rtlCol="0" anchor="ctr"/>
-          <a:lstStyle/>
-          <a:p>
-            <a:pPr algn="ctr" indent="0" marL="0">
-              <a:buNone/>
-            </a:pPr>
-            <a:r>
-              <a:rPr lang="en-US" sz="1500" b="1" spc="200" kern="0" dirty="0">
-                <a:solidFill>
-                  <a:srgbClr val="C9A84C"/>
-                </a:solidFill>
-                <a:latin typeface="Calibri" pitchFamily="34" charset="0"/>
-                <a:ea typeface="Calibri" pitchFamily="34" charset="-122"/>
-                <a:cs typeface="Calibri" pitchFamily="34" charset="-120"/>
-              </a:rPr>
-              <a:t>FIRST UP: DAMAC LAGOONS - HANDING OVER NOW. I WORK THESE STREETS EVERY DAY.</a:t>
-            </a:r>
-            <a:endParaRPr lang="en-US" sz="1500" dirty="0"/>
           </a:p>
         </p:txBody>
       </p:sp>
@@ -2362,8 +2284,8 @@
         </p:blipFill>
         <p:spPr>
           <a:xfrm>
-            <a:off x="3405073" y="411480"/>
-            <a:ext cx="5378806" cy="6309360"/>
+            <a:off x="2873473" y="411480"/>
+            <a:ext cx="6442007" cy="6309360"/>
           </a:xfrm>
           <a:prstGeom prst="rect">
             <a:avLst/>

</xml_diff>

<commit_message>
EP1 v4: full-width SOA incl right column, house reframed
</commit_message>
<xml_diff>
--- a/content-assets/lagoons-ep1/lagoons-review-ep1.pptx
+++ b/content-assets/lagoons-ep1/lagoons-review-ep1.pptx
@@ -2284,8 +2284,8 @@
         </p:blipFill>
         <p:spPr>
           <a:xfrm>
-            <a:off x="2873473" y="411480"/>
-            <a:ext cx="6442007" cy="6309360"/>
+            <a:off x="2694688" y="411480"/>
+            <a:ext cx="6799575" cy="6309360"/>
           </a:xfrm>
           <a:prstGeom prst="rect">
             <a:avLst/>

</xml_diff>